<commit_message>
This version of Antigravity is no longer supported. Please upgrade to receive the latest features.
</commit_message>
<xml_diff>
--- a/slide/PROJETO PERFORMANCE.pptx
+++ b/slide/PROJETO PERFORMANCE.pptx
@@ -546,12 +546,6 @@
             <c:idx val="0"/>
             <c:invertIfNegative val="0"/>
             <c:bubble3D val="0"/>
-            <c:spPr>
-              <a:solidFill>
-                <a:srgbClr val="DC2626"/>
-              </a:solidFill>
-              <a:effectLst/>
-            </c:spPr>
             <c:extLst>
               <c:ext xmlns:c16="http://schemas.microsoft.com/office/drawing/2014/chart" uri="{C3380CC4-5D6E-409C-BE32-E72D297353CC}">
                 <c16:uniqueId val="{00000001-FD8F-46D8-8358-DAEDC48812C4}"/>
@@ -2736,6 +2730,67 @@
               <a:t>Node.js</a:t>
             </a:r>
             <a:endParaRPr lang="en-US" sz="1100" dirty="0"/>
+          </a:p>
+        </p:txBody>
+      </p:sp>
+      <p:sp>
+        <p:nvSpPr>
+          <p:cNvPr id="18" name="Text 2">
+            <a:extLst>
+              <a:ext uri="{FF2B5EF4-FFF2-40B4-BE49-F238E27FC236}">
+                <a16:creationId xmlns:a16="http://schemas.microsoft.com/office/drawing/2014/main" id="{F8509F29-A491-F1BC-6A07-6B273316ABD9}"/>
+              </a:ext>
+            </a:extLst>
+          </p:cNvPr>
+          <p:cNvSpPr/>
+          <p:nvPr/>
+        </p:nvSpPr>
+        <p:spPr>
+          <a:xfrm>
+            <a:off x="372292" y="4136571"/>
+            <a:ext cx="7791994" cy="916577"/>
+          </a:xfrm>
+          <a:prstGeom prst="rect">
+            <a:avLst/>
+          </a:prstGeom>
+          <a:noFill/>
+          <a:ln/>
+        </p:spPr>
+        <p:txBody>
+          <a:bodyPr wrap="square" rtlCol="0" anchor="ctr"/>
+          <a:lstStyle/>
+          <a:p>
+            <a:pPr marL="0" indent="0">
+              <a:buNone/>
+            </a:pPr>
+            <a:r>
+              <a:rPr lang="en-US" sz="2000" dirty="0">
+                <a:solidFill>
+                  <a:srgbClr val="14B8A6"/>
+                </a:solidFill>
+                <a:latin typeface="Calibri" pitchFamily="34" charset="0"/>
+                <a:ea typeface="Calibri" pitchFamily="34" charset="-122"/>
+                <a:cs typeface="Calibri" pitchFamily="34" charset="-120"/>
+              </a:rPr>
+              <a:t>Gabriel Aires; </a:t>
+            </a:r>
+          </a:p>
+          <a:p>
+            <a:pPr marL="0" indent="0">
+              <a:buNone/>
+            </a:pPr>
+            <a:r>
+              <a:rPr lang="en-US" sz="2000" dirty="0">
+                <a:solidFill>
+                  <a:srgbClr val="14B8A6"/>
+                </a:solidFill>
+                <a:latin typeface="Calibri" pitchFamily="34" charset="0"/>
+                <a:ea typeface="Calibri" pitchFamily="34" charset="-122"/>
+                <a:cs typeface="Calibri" pitchFamily="34" charset="-120"/>
+              </a:rPr>
+              <a:t>João Victor;</a:t>
+            </a:r>
+            <a:endParaRPr lang="en-US" sz="2000" dirty="0"/>
           </a:p>
         </p:txBody>
       </p:sp>

</xml_diff>

<commit_message>
docs: add performance project presentation slides
</commit_message>
<xml_diff>
--- a/slide/PROJETO PERFORMANCE.pptx
+++ b/slide/PROJETO PERFORMANCE.pptx
@@ -8485,6 +8485,16 @@
             <a:prstDash val="dash"/>
           </a:ln>
         </p:spPr>
+        <p:txBody>
+          <a:bodyPr/>
+          <a:lstStyle/>
+          <a:p>
+            <a:r>
+              <a:rPr lang="pt-BR" dirty="0"/>
+              <a:t>v</a:t>
+            </a:r>
+          </a:p>
+        </p:txBody>
       </p:sp>
       <p:sp>
         <p:nvSpPr>
@@ -8974,7 +8984,7 @@
         <p:spPr>
           <a:xfrm>
             <a:off x="7406640" y="2834640"/>
-            <a:ext cx="1828800" cy="914400"/>
+            <a:ext cx="1639389" cy="914400"/>
           </a:xfrm>
           <a:prstGeom prst="rect">
             <a:avLst/>
@@ -9272,7 +9282,7 @@
         <p:spPr>
           <a:xfrm>
             <a:off x="7406640" y="3886200"/>
-            <a:ext cx="1828800" cy="914400"/>
+            <a:ext cx="1639389" cy="914400"/>
           </a:xfrm>
           <a:prstGeom prst="rect">
             <a:avLst/>
@@ -9411,6 +9421,35 @@
             <a:endParaRPr lang="en-US" sz="800" dirty="0"/>
           </a:p>
         </p:txBody>
+      </p:sp>
+      <p:sp>
+        <p:nvSpPr>
+          <p:cNvPr id="38" name="Shape 14">
+            <a:extLst>
+              <a:ext uri="{FF2B5EF4-FFF2-40B4-BE49-F238E27FC236}">
+                <a16:creationId xmlns:a16="http://schemas.microsoft.com/office/drawing/2014/main" id="{50CCB11A-67F7-F5D0-099D-ABEF01D504D9}"/>
+              </a:ext>
+            </a:extLst>
+          </p:cNvPr>
+          <p:cNvSpPr/>
+          <p:nvPr/>
+        </p:nvSpPr>
+        <p:spPr>
+          <a:xfrm flipV="1">
+            <a:off x="7315200" y="1920240"/>
+            <a:ext cx="0" cy="731516"/>
+          </a:xfrm>
+          <a:prstGeom prst="line">
+            <a:avLst/>
+          </a:prstGeom>
+          <a:noFill/>
+          <a:ln w="19050">
+            <a:solidFill>
+              <a:srgbClr val="16A34A"/>
+            </a:solidFill>
+            <a:prstDash val="dash"/>
+          </a:ln>
+        </p:spPr>
       </p:sp>
     </p:spTree>
   </p:cSld>
@@ -10288,7 +10327,7 @@
         <p:spPr>
           <a:xfrm>
             <a:off x="7315200" y="868680"/>
-            <a:ext cx="1828800" cy="1325880"/>
+            <a:ext cx="1763486" cy="1325880"/>
           </a:xfrm>
           <a:prstGeom prst="rect">
             <a:avLst/>
@@ -10586,7 +10625,7 @@
         <p:spPr>
           <a:xfrm>
             <a:off x="7315200" y="2377440"/>
-            <a:ext cx="1828800" cy="1325880"/>
+            <a:ext cx="1763486" cy="1325880"/>
           </a:xfrm>
           <a:prstGeom prst="rect">
             <a:avLst/>

</xml_diff>